<commit_message>
simple fixes and readme update
</commit_message>
<xml_diff>
--- a/imspres.pptx
+++ b/imspres.pptx
@@ -5,7 +5,7 @@
     <p:sldMasterId id="2147483648" r:id="rId1"/>
   </p:sldMasterIdLst>
   <p:notesMasterIdLst>
-    <p:notesMasterId r:id="rId11"/>
+    <p:notesMasterId r:id="rId10"/>
   </p:notesMasterIdLst>
   <p:sldIdLst>
     <p:sldId id="256" r:id="rId2"/>
@@ -16,7 +16,6 @@
     <p:sldId id="258" r:id="rId7"/>
     <p:sldId id="261" r:id="rId8"/>
     <p:sldId id="262" r:id="rId9"/>
-    <p:sldId id="265" r:id="rId10"/>
   </p:sldIdLst>
   <p:sldSz cx="12192000" cy="6858000"/>
   <p:notesSz cx="6858000" cy="9144000"/>
@@ -205,7 +204,7 @@
           <a:p>
             <a:fld id="{3BFF3F78-CC4C-4410-BD19-50E9966652FF}" type="datetimeFigureOut">
               <a:rPr lang="en-GB" smtClean="0"/>
-              <a:t>27/05/2022</a:t>
+              <a:t>07/09/2026</a:t>
             </a:fld>
             <a:endParaRPr lang="en-GB"/>
           </a:p>
@@ -726,7 +725,7 @@
           <a:p>
             <a:fld id="{7C1CA276-63AD-478F-8735-7F598CABE76B}" type="datetimeFigureOut">
               <a:rPr lang="en-GB" smtClean="0"/>
-              <a:t>27/05/2022</a:t>
+              <a:t>07/09/2026</a:t>
             </a:fld>
             <a:endParaRPr lang="en-GB"/>
           </a:p>
@@ -926,7 +925,7 @@
           <a:p>
             <a:fld id="{7C1CA276-63AD-478F-8735-7F598CABE76B}" type="datetimeFigureOut">
               <a:rPr lang="en-GB" smtClean="0"/>
-              <a:t>27/05/2022</a:t>
+              <a:t>07/09/2026</a:t>
             </a:fld>
             <a:endParaRPr lang="en-GB"/>
           </a:p>
@@ -1136,7 +1135,7 @@
           <a:p>
             <a:fld id="{7C1CA276-63AD-478F-8735-7F598CABE76B}" type="datetimeFigureOut">
               <a:rPr lang="en-GB" smtClean="0"/>
-              <a:t>27/05/2022</a:t>
+              <a:t>07/09/2026</a:t>
             </a:fld>
             <a:endParaRPr lang="en-GB"/>
           </a:p>
@@ -1336,7 +1335,7 @@
           <a:p>
             <a:fld id="{7C1CA276-63AD-478F-8735-7F598CABE76B}" type="datetimeFigureOut">
               <a:rPr lang="en-GB" smtClean="0"/>
-              <a:t>27/05/2022</a:t>
+              <a:t>07/09/2026</a:t>
             </a:fld>
             <a:endParaRPr lang="en-GB"/>
           </a:p>
@@ -1612,7 +1611,7 @@
           <a:p>
             <a:fld id="{7C1CA276-63AD-478F-8735-7F598CABE76B}" type="datetimeFigureOut">
               <a:rPr lang="en-GB" smtClean="0"/>
-              <a:t>27/05/2022</a:t>
+              <a:t>07/09/2026</a:t>
             </a:fld>
             <a:endParaRPr lang="en-GB"/>
           </a:p>
@@ -1880,7 +1879,7 @@
           <a:p>
             <a:fld id="{7C1CA276-63AD-478F-8735-7F598CABE76B}" type="datetimeFigureOut">
               <a:rPr lang="en-GB" smtClean="0"/>
-              <a:t>27/05/2022</a:t>
+              <a:t>07/09/2026</a:t>
             </a:fld>
             <a:endParaRPr lang="en-GB"/>
           </a:p>
@@ -2295,7 +2294,7 @@
           <a:p>
             <a:fld id="{7C1CA276-63AD-478F-8735-7F598CABE76B}" type="datetimeFigureOut">
               <a:rPr lang="en-GB" smtClean="0"/>
-              <a:t>27/05/2022</a:t>
+              <a:t>07/09/2026</a:t>
             </a:fld>
             <a:endParaRPr lang="en-GB"/>
           </a:p>
@@ -2437,7 +2436,7 @@
           <a:p>
             <a:fld id="{7C1CA276-63AD-478F-8735-7F598CABE76B}" type="datetimeFigureOut">
               <a:rPr lang="en-GB" smtClean="0"/>
-              <a:t>27/05/2022</a:t>
+              <a:t>07/09/2026</a:t>
             </a:fld>
             <a:endParaRPr lang="en-GB"/>
           </a:p>
@@ -2550,7 +2549,7 @@
           <a:p>
             <a:fld id="{7C1CA276-63AD-478F-8735-7F598CABE76B}" type="datetimeFigureOut">
               <a:rPr lang="en-GB" smtClean="0"/>
-              <a:t>27/05/2022</a:t>
+              <a:t>07/09/2026</a:t>
             </a:fld>
             <a:endParaRPr lang="en-GB"/>
           </a:p>
@@ -2863,7 +2862,7 @@
           <a:p>
             <a:fld id="{7C1CA276-63AD-478F-8735-7F598CABE76B}" type="datetimeFigureOut">
               <a:rPr lang="en-GB" smtClean="0"/>
-              <a:t>27/05/2022</a:t>
+              <a:t>07/09/2026</a:t>
             </a:fld>
             <a:endParaRPr lang="en-GB"/>
           </a:p>
@@ -3152,7 +3151,7 @@
           <a:p>
             <a:fld id="{7C1CA276-63AD-478F-8735-7F598CABE76B}" type="datetimeFigureOut">
               <a:rPr lang="en-GB" smtClean="0"/>
-              <a:t>27/05/2022</a:t>
+              <a:t>07/09/2026</a:t>
             </a:fld>
             <a:endParaRPr lang="en-GB"/>
           </a:p>
@@ -3395,7 +3394,7 @@
           <a:p>
             <a:fld id="{7C1CA276-63AD-478F-8735-7F598CABE76B}" type="datetimeFigureOut">
               <a:rPr lang="en-GB" smtClean="0"/>
-              <a:t>27/05/2022</a:t>
+              <a:t>07/09/2026</a:t>
             </a:fld>
             <a:endParaRPr lang="en-GB"/>
           </a:p>
@@ -5448,422 +5447,6 @@
 </p:sld>
 </file>
 
-<file path=ppt/slides/slide9.xml><?xml version="1.0" encoding="utf-8"?>
-<p:sld xmlns:a="http://schemas.openxmlformats.org/drawingml/2006/main" xmlns:r="http://schemas.openxmlformats.org/officeDocument/2006/relationships" xmlns:p="http://schemas.openxmlformats.org/presentationml/2006/main">
-  <p:cSld>
-    <p:spTree>
-      <p:nvGrpSpPr>
-        <p:cNvPr id="1" name=""/>
-        <p:cNvGrpSpPr/>
-        <p:nvPr/>
-      </p:nvGrpSpPr>
-      <p:grpSpPr>
-        <a:xfrm>
-          <a:off x="0" y="0"/>
-          <a:ext cx="0" cy="0"/>
-          <a:chOff x="0" y="0"/>
-          <a:chExt cx="0" cy="0"/>
-        </a:xfrm>
-      </p:grpSpPr>
-      <p:sp>
-        <p:nvSpPr>
-          <p:cNvPr id="2" name="Title 1">
-            <a:extLst>
-              <a:ext uri="{FF2B5EF4-FFF2-40B4-BE49-F238E27FC236}">
-                <a16:creationId xmlns:a16="http://schemas.microsoft.com/office/drawing/2014/main" id="{BFD2097D-E834-BC93-8A6B-BF1EBF628AA1}"/>
-              </a:ext>
-            </a:extLst>
-          </p:cNvPr>
-          <p:cNvSpPr>
-            <a:spLocks noGrp="1"/>
-          </p:cNvSpPr>
-          <p:nvPr>
-            <p:ph type="title"/>
-          </p:nvPr>
-        </p:nvSpPr>
-        <p:spPr/>
-        <p:txBody>
-          <a:bodyPr/>
-          <a:lstStyle/>
-          <a:p>
-            <a:r>
-              <a:rPr lang="en-GB" dirty="0"/>
-              <a:t>Reflections</a:t>
-            </a:r>
-          </a:p>
-        </p:txBody>
-      </p:sp>
-      <p:graphicFrame>
-        <p:nvGraphicFramePr>
-          <p:cNvPr id="4" name="Table 4">
-            <a:extLst>
-              <a:ext uri="{FF2B5EF4-FFF2-40B4-BE49-F238E27FC236}">
-                <a16:creationId xmlns:a16="http://schemas.microsoft.com/office/drawing/2014/main" id="{8CCD8CDA-B35C-A415-6CD6-1A16B2D0BC1D}"/>
-              </a:ext>
-            </a:extLst>
-          </p:cNvPr>
-          <p:cNvGraphicFramePr>
-            <a:graphicFrameLocks noGrp="1"/>
-          </p:cNvGraphicFramePr>
-          <p:nvPr>
-            <p:extLst>
-              <p:ext uri="{D42A27DB-BD31-4B8C-83A1-F6EECF244321}">
-                <p14:modId xmlns:p14="http://schemas.microsoft.com/office/powerpoint/2010/main" val="2490743702"/>
-              </p:ext>
-            </p:extLst>
-          </p:nvPr>
-        </p:nvGraphicFramePr>
-        <p:xfrm>
-          <a:off x="513126" y="2144456"/>
-          <a:ext cx="11165747" cy="3267298"/>
-        </p:xfrm>
-        <a:graphic>
-          <a:graphicData uri="http://schemas.openxmlformats.org/drawingml/2006/table">
-            <a:tbl>
-              <a:tblPr firstRow="1" bandRow="1">
-                <a:tableStyleId>{5C22544A-7EE6-4342-B048-85BDC9FD1C3A}</a:tableStyleId>
-              </a:tblPr>
-              <a:tblGrid>
-                <a:gridCol w="3428677">
-                  <a:extLst>
-                    <a:ext uri="{9D8B030D-6E8A-4147-A177-3AD203B41FA5}">
-                      <a16:colId xmlns:a16="http://schemas.microsoft.com/office/drawing/2014/main" val="1366440091"/>
-                    </a:ext>
-                  </a:extLst>
-                </a:gridCol>
-                <a:gridCol w="247797">
-                  <a:extLst>
-                    <a:ext uri="{9D8B030D-6E8A-4147-A177-3AD203B41FA5}">
-                      <a16:colId xmlns:a16="http://schemas.microsoft.com/office/drawing/2014/main" val="2878226852"/>
-                    </a:ext>
-                  </a:extLst>
-                </a:gridCol>
-                <a:gridCol w="3620738">
-                  <a:extLst>
-                    <a:ext uri="{9D8B030D-6E8A-4147-A177-3AD203B41FA5}">
-                      <a16:colId xmlns:a16="http://schemas.microsoft.com/office/drawing/2014/main" val="262802528"/>
-                    </a:ext>
-                  </a:extLst>
-                </a:gridCol>
-                <a:gridCol w="247797">
-                  <a:extLst>
-                    <a:ext uri="{9D8B030D-6E8A-4147-A177-3AD203B41FA5}">
-                      <a16:colId xmlns:a16="http://schemas.microsoft.com/office/drawing/2014/main" val="1972536911"/>
-                    </a:ext>
-                  </a:extLst>
-                </a:gridCol>
-                <a:gridCol w="3620738">
-                  <a:extLst>
-                    <a:ext uri="{9D8B030D-6E8A-4147-A177-3AD203B41FA5}">
-                      <a16:colId xmlns:a16="http://schemas.microsoft.com/office/drawing/2014/main" val="2423662359"/>
-                    </a:ext>
-                  </a:extLst>
-                </a:gridCol>
-              </a:tblGrid>
-              <a:tr h="3267298">
-                <a:tc>
-                  <a:txBody>
-                    <a:bodyPr/>
-                    <a:lstStyle/>
-                    <a:p>
-                      <a:r>
-                        <a:rPr lang="en-GB" dirty="0">
-                          <a:solidFill>
-                            <a:schemeClr val="tx1"/>
-                          </a:solidFill>
-                        </a:rPr>
-                        <a:t>WHAT WENT WELL</a:t>
-                      </a:r>
-                    </a:p>
-                    <a:p>
-                      <a:endParaRPr lang="en-GB" dirty="0">
-                        <a:solidFill>
-                          <a:schemeClr val="tx1"/>
-                        </a:solidFill>
-                      </a:endParaRPr>
-                    </a:p>
-                    <a:p>
-                      <a:pPr marL="285750" indent="-285750">
-                        <a:buFontTx/>
-                        <a:buChar char="-"/>
-                      </a:pPr>
-                      <a:r>
-                        <a:rPr lang="en-GB" dirty="0">
-                          <a:solidFill>
-                            <a:schemeClr val="tx1"/>
-                          </a:solidFill>
-                        </a:rPr>
-                        <a:t>MVP achieved</a:t>
-                      </a:r>
-                    </a:p>
-                    <a:p>
-                      <a:pPr marL="285750" indent="-285750">
-                        <a:buFontTx/>
-                        <a:buChar char="-"/>
-                      </a:pPr>
-                      <a:r>
-                        <a:rPr lang="en-GB" dirty="0">
-                          <a:solidFill>
-                            <a:schemeClr val="tx1"/>
-                          </a:solidFill>
-                        </a:rPr>
-                        <a:t>Gives user another chance to input if they enter the wrong thing in the CLI</a:t>
-                      </a:r>
-                    </a:p>
-                    <a:p>
-                      <a:pPr marL="285750" indent="-285750">
-                        <a:buFontTx/>
-                        <a:buChar char="-"/>
-                      </a:pPr>
-                      <a:endParaRPr lang="en-GB" dirty="0">
-                        <a:solidFill>
-                          <a:schemeClr val="tx1"/>
-                        </a:solidFill>
-                      </a:endParaRPr>
-                    </a:p>
-                  </a:txBody>
-                  <a:tcPr>
-                    <a:solidFill>
-                      <a:schemeClr val="bg1"/>
-                    </a:solidFill>
-                  </a:tcPr>
-                </a:tc>
-                <a:tc>
-                  <a:txBody>
-                    <a:bodyPr/>
-                    <a:lstStyle/>
-                    <a:p>
-                      <a:endParaRPr lang="en-GB" dirty="0">
-                        <a:solidFill>
-                          <a:schemeClr val="tx1"/>
-                        </a:solidFill>
-                      </a:endParaRPr>
-                    </a:p>
-                  </a:txBody>
-                  <a:tcPr>
-                    <a:solidFill>
-                      <a:schemeClr val="bg1"/>
-                    </a:solidFill>
-                  </a:tcPr>
-                </a:tc>
-                <a:tc>
-                  <a:txBody>
-                    <a:bodyPr/>
-                    <a:lstStyle/>
-                    <a:p>
-                      <a:r>
-                        <a:rPr lang="en-GB" dirty="0">
-                          <a:solidFill>
-                            <a:schemeClr val="tx1"/>
-                          </a:solidFill>
-                        </a:rPr>
-                        <a:t>WHAT DIDN’T GO WELL</a:t>
-                      </a:r>
-                    </a:p>
-                    <a:p>
-                      <a:endParaRPr lang="en-GB" dirty="0">
-                        <a:solidFill>
-                          <a:schemeClr val="tx1"/>
-                        </a:solidFill>
-                      </a:endParaRPr>
-                    </a:p>
-                    <a:p>
-                      <a:pPr marL="285750" indent="-285750">
-                        <a:buFontTx/>
-                        <a:buChar char="-"/>
-                      </a:pPr>
-                      <a:r>
-                        <a:rPr lang="en-GB" dirty="0">
-                          <a:solidFill>
-                            <a:schemeClr val="tx1"/>
-                          </a:solidFill>
-                        </a:rPr>
-                        <a:t>Ran out of time </a:t>
-                      </a:r>
-                      <a:r>
-                        <a:rPr lang="en-GB" dirty="0">
-                          <a:solidFill>
-                            <a:schemeClr val="tx1"/>
-                          </a:solidFill>
-                          <a:sym typeface="Wingdings" panose="05000000000000000000" pitchFamily="2" charset="2"/>
-                        </a:rPr>
-                        <a:t>due to illness</a:t>
-                      </a:r>
-                    </a:p>
-                    <a:p>
-                      <a:pPr marL="285750" indent="-285750">
-                        <a:buFontTx/>
-                        <a:buChar char="-"/>
-                      </a:pPr>
-                      <a:r>
-                        <a:rPr lang="en-GB" dirty="0">
-                          <a:solidFill>
-                            <a:schemeClr val="tx1"/>
-                          </a:solidFill>
-                          <a:sym typeface="Wingdings" panose="05000000000000000000" pitchFamily="2" charset="2"/>
-                        </a:rPr>
-                        <a:t>Relationships between tables not established </a:t>
-                      </a:r>
-                    </a:p>
-                    <a:p>
-                      <a:pPr marL="285750" indent="-285750">
-                        <a:buFontTx/>
-                        <a:buChar char="-"/>
-                      </a:pPr>
-                      <a:r>
-                        <a:rPr lang="en-GB" dirty="0">
-                          <a:solidFill>
-                            <a:schemeClr val="tx1"/>
-                          </a:solidFill>
-                          <a:sym typeface="Wingdings" panose="05000000000000000000" pitchFamily="2" charset="2"/>
-                        </a:rPr>
-                        <a:t>Issues with some tests</a:t>
-                      </a:r>
-                    </a:p>
-                    <a:p>
-                      <a:pPr marL="285750" indent="-285750">
-                        <a:buFontTx/>
-                        <a:buChar char="-"/>
-                      </a:pPr>
-                      <a:r>
-                        <a:rPr lang="en-GB" dirty="0">
-                          <a:solidFill>
-                            <a:schemeClr val="tx1"/>
-                          </a:solidFill>
-                          <a:sym typeface="Wingdings" panose="05000000000000000000" pitchFamily="2" charset="2"/>
-                        </a:rPr>
-                        <a:t>Work is pushed to dev but not master because of merge conflicts</a:t>
-                      </a:r>
-                    </a:p>
-                    <a:p>
-                      <a:pPr marL="285750" indent="-285750">
-                        <a:buFontTx/>
-                        <a:buChar char="-"/>
-                      </a:pPr>
-                      <a:endParaRPr lang="en-GB" dirty="0">
-                        <a:solidFill>
-                          <a:schemeClr val="tx1"/>
-                        </a:solidFill>
-                      </a:endParaRPr>
-                    </a:p>
-                  </a:txBody>
-                  <a:tcPr>
-                    <a:solidFill>
-                      <a:schemeClr val="bg1"/>
-                    </a:solidFill>
-                  </a:tcPr>
-                </a:tc>
-                <a:tc>
-                  <a:txBody>
-                    <a:bodyPr/>
-                    <a:lstStyle/>
-                    <a:p>
-                      <a:endParaRPr lang="en-GB" dirty="0">
-                        <a:solidFill>
-                          <a:schemeClr val="tx1"/>
-                        </a:solidFill>
-                      </a:endParaRPr>
-                    </a:p>
-                  </a:txBody>
-                  <a:tcPr>
-                    <a:solidFill>
-                      <a:schemeClr val="bg1"/>
-                    </a:solidFill>
-                  </a:tcPr>
-                </a:tc>
-                <a:tc>
-                  <a:txBody>
-                    <a:bodyPr/>
-                    <a:lstStyle/>
-                    <a:p>
-                      <a:r>
-                        <a:rPr lang="en-GB" dirty="0">
-                          <a:solidFill>
-                            <a:schemeClr val="tx1"/>
-                          </a:solidFill>
-                        </a:rPr>
-                        <a:t>IMPROVEMENTS</a:t>
-                      </a:r>
-                    </a:p>
-                    <a:p>
-                      <a:endParaRPr lang="en-GB" dirty="0">
-                        <a:solidFill>
-                          <a:schemeClr val="tx1"/>
-                        </a:solidFill>
-                      </a:endParaRPr>
-                    </a:p>
-                    <a:p>
-                      <a:pPr marL="285750" indent="-285750">
-                        <a:buFontTx/>
-                        <a:buChar char="-"/>
-                      </a:pPr>
-                      <a:r>
-                        <a:rPr lang="en-GB" dirty="0">
-                          <a:solidFill>
-                            <a:schemeClr val="tx1"/>
-                          </a:solidFill>
-                        </a:rPr>
-                        <a:t>Account for time better</a:t>
-                      </a:r>
-                    </a:p>
-                    <a:p>
-                      <a:pPr marL="285750" indent="-285750">
-                        <a:buFontTx/>
-                        <a:buChar char="-"/>
-                      </a:pPr>
-                      <a:r>
-                        <a:rPr lang="en-GB" dirty="0">
-                          <a:solidFill>
-                            <a:schemeClr val="tx1"/>
-                          </a:solidFill>
-                        </a:rPr>
-                        <a:t>Improve Jira setup – add more detail</a:t>
-                      </a:r>
-                    </a:p>
-                    <a:p>
-                      <a:pPr marL="285750" indent="-285750">
-                        <a:buFontTx/>
-                        <a:buChar char="-"/>
-                      </a:pPr>
-                      <a:r>
-                        <a:rPr lang="en-GB" dirty="0">
-                          <a:solidFill>
-                            <a:schemeClr val="tx1"/>
-                          </a:solidFill>
-                        </a:rPr>
-                        <a:t>Revise over GitHub and commands to avoid further conflicts</a:t>
-                      </a:r>
-                    </a:p>
-                  </a:txBody>
-                  <a:tcPr>
-                    <a:solidFill>
-                      <a:schemeClr val="bg1"/>
-                    </a:solidFill>
-                  </a:tcPr>
-                </a:tc>
-                <a:extLst>
-                  <a:ext uri="{0D108BD9-81ED-4DB2-BD59-A6C34878D82A}">
-                    <a16:rowId xmlns:a16="http://schemas.microsoft.com/office/drawing/2014/main" val="54743179"/>
-                  </a:ext>
-                </a:extLst>
-              </a:tr>
-            </a:tbl>
-          </a:graphicData>
-        </a:graphic>
-      </p:graphicFrame>
-    </p:spTree>
-    <p:extLst>
-      <p:ext uri="{BB962C8B-B14F-4D97-AF65-F5344CB8AC3E}">
-        <p14:creationId xmlns:p14="http://schemas.microsoft.com/office/powerpoint/2010/main" val="2283213072"/>
-      </p:ext>
-    </p:extLst>
-  </p:cSld>
-  <p:clrMapOvr>
-    <a:masterClrMapping/>
-  </p:clrMapOvr>
-</p:sld>
-</file>
-
 <file path=ppt/theme/theme1.xml><?xml version="1.0" encoding="utf-8"?>
 <a:theme xmlns:a="http://schemas.openxmlformats.org/drawingml/2006/main" name="Office Theme">
   <a:themeElements>

</xml_diff>